<commit_message>
docs(entregables): quitar slide de Resultados del pptx
Co-Authored-By: Claude Opus 4.8 <noreply@anthropic.com>
Claude-Session: https://claude.ai/code/session_012h3MUQVE2yiu9KbMk4RVwD
</commit_message>
<xml_diff>
--- a/docs/entregables/TP-Final-Coding-Agent.pptx
+++ b/docs/entregables/TP-Final-Coding-Agent.pptx
@@ -20,7 +20,6 @@
     <p:sldId id="268" r:id="rId19"/>
     <p:sldId id="269" r:id="rId20"/>
     <p:sldId id="270" r:id="rId21"/>
-    <p:sldId id="271" r:id="rId22"/>
   </p:sldIdLst>
   <p:sldSz cx="12191695" cy="6858000" type="screen4x3"/>
   <p:notesSz cx="6858000" cy="9144000"/>
@@ -5331,759 +5330,6 @@
 </file>
 
 <file path=ppt/slides/slide15.xml><?xml version="1.0" encoding="utf-8"?>
-<p:sld xmlns:a="http://schemas.openxmlformats.org/drawingml/2006/main" xmlns:p="http://schemas.openxmlformats.org/presentationml/2006/main" xmlns:r="http://schemas.openxmlformats.org/officeDocument/2006/relationships">
-  <p:cSld>
-    <p:spTree>
-      <p:nvGrpSpPr>
-        <p:cNvPr id="1" name=""/>
-        <p:cNvGrpSpPr/>
-        <p:nvPr/>
-      </p:nvGrpSpPr>
-      <p:grpSpPr/>
-      <p:sp>
-        <p:nvSpPr>
-          <p:cNvPr id="2" name="Rectangle 1"/>
-          <p:cNvSpPr/>
-          <p:nvPr/>
-        </p:nvSpPr>
-        <p:spPr>
-          <a:xfrm>
-            <a:off x="0" y="0"/>
-            <a:ext cx="12191695" cy="6858000"/>
-          </a:xfrm>
-          <a:prstGeom prst="rect">
-            <a:avLst/>
-          </a:prstGeom>
-          <a:solidFill>
-            <a:srgbClr val="0E1017"/>
-          </a:solidFill>
-          <a:ln>
-            <a:noFill/>
-          </a:ln>
-          <a:effectLst/>
-        </p:spPr>
-        <p:style>
-          <a:lnRef idx="1">
-            <a:schemeClr val="accent1"/>
-          </a:lnRef>
-          <a:fillRef idx="3">
-            <a:schemeClr val="accent1"/>
-          </a:fillRef>
-          <a:effectRef idx="2">
-            <a:schemeClr val="accent1"/>
-          </a:effectRef>
-          <a:fontRef idx="minor">
-            <a:schemeClr val="lt1"/>
-          </a:fontRef>
-        </p:style>
-        <p:txBody>
-          <a:bodyPr rtlCol="0" anchor="ctr"/>
-          <a:lstStyle/>
-          <a:p>
-            <a:pPr algn="ctr"/>
-          </a:p>
-        </p:txBody>
-      </p:sp>
-      <p:sp>
-        <p:nvSpPr>
-          <p:cNvPr id="3" name="TextBox 2"/>
-          <p:cNvSpPr txBox="1"/>
-          <p:nvPr/>
-        </p:nvSpPr>
-        <p:spPr>
-          <a:xfrm>
-            <a:off x="822960" y="502920"/>
-            <a:ext cx="10545775" cy="365760"/>
-          </a:xfrm>
-          <a:prstGeom prst="rect">
-            <a:avLst/>
-          </a:prstGeom>
-          <a:noFill/>
-        </p:spPr>
-        <p:txBody>
-          <a:bodyPr wrap="square" anchor="t" lIns="0" rIns="0" tIns="0" bIns="0">
-            <a:spAutoFit/>
-          </a:bodyPr>
-          <a:lstStyle/>
-          <a:p>
-            <a:r>
-              <a:rPr sz="1200" b="1">
-                <a:solidFill>
-                  <a:srgbClr val="E0A145"/>
-                </a:solidFill>
-                <a:latin typeface="Consolas"/>
-              </a:rPr>
-              <a:t>12 · RESULTADOS</a:t>
-            </a:r>
-          </a:p>
-        </p:txBody>
-      </p:sp>
-      <p:sp>
-        <p:nvSpPr>
-          <p:cNvPr id="4" name="Rectangle 3"/>
-          <p:cNvSpPr/>
-          <p:nvPr/>
-        </p:nvSpPr>
-        <p:spPr>
-          <a:xfrm>
-            <a:off x="822960" y="868680"/>
-            <a:ext cx="320040" cy="31750"/>
-          </a:xfrm>
-          <a:prstGeom prst="rect">
-            <a:avLst/>
-          </a:prstGeom>
-          <a:solidFill>
-            <a:srgbClr val="E0A145"/>
-          </a:solidFill>
-          <a:ln>
-            <a:noFill/>
-          </a:ln>
-          <a:effectLst/>
-        </p:spPr>
-        <p:style>
-          <a:lnRef idx="1">
-            <a:schemeClr val="accent1"/>
-          </a:lnRef>
-          <a:fillRef idx="3">
-            <a:schemeClr val="accent1"/>
-          </a:fillRef>
-          <a:effectRef idx="2">
-            <a:schemeClr val="accent1"/>
-          </a:effectRef>
-          <a:fontRef idx="minor">
-            <a:schemeClr val="lt1"/>
-          </a:fontRef>
-        </p:style>
-        <p:txBody>
-          <a:bodyPr rtlCol="0" anchor="ctr"/>
-          <a:lstStyle/>
-          <a:p>
-            <a:pPr algn="ctr"/>
-          </a:p>
-        </p:txBody>
-      </p:sp>
-      <p:sp>
-        <p:nvSpPr>
-          <p:cNvPr id="5" name="TextBox 4"/>
-          <p:cNvSpPr txBox="1"/>
-          <p:nvPr/>
-        </p:nvSpPr>
-        <p:spPr>
-          <a:xfrm>
-            <a:off x="822960" y="1051560"/>
-            <a:ext cx="10545775" cy="1005840"/>
-          </a:xfrm>
-          <a:prstGeom prst="rect">
-            <a:avLst/>
-          </a:prstGeom>
-          <a:noFill/>
-        </p:spPr>
-        <p:txBody>
-          <a:bodyPr wrap="square" anchor="t" lIns="0" rIns="0" tIns="0" bIns="0">
-            <a:spAutoFit/>
-          </a:bodyPr>
-          <a:lstStyle/>
-          <a:p>
-            <a:r>
-              <a:rPr sz="3000" b="1">
-                <a:solidFill>
-                  <a:srgbClr val="EEF0F6"/>
-                </a:solidFill>
-                <a:latin typeface="Segoe UI"/>
-              </a:rPr>
-              <a:t>El flujo completa el ciclo, de forma verificable.</a:t>
-            </a:r>
-          </a:p>
-        </p:txBody>
-      </p:sp>
-      <p:sp>
-        <p:nvSpPr>
-          <p:cNvPr id="6" name="Rounded Rectangle 5"/>
-          <p:cNvSpPr/>
-          <p:nvPr/>
-        </p:nvSpPr>
-        <p:spPr>
-          <a:xfrm>
-            <a:off x="822960" y="2286000"/>
-            <a:ext cx="5090007" cy="960120"/>
-          </a:xfrm>
-          <a:prstGeom prst="roundRect">
-            <a:avLst>
-              <a:gd name="adj" fmla="val 6000"/>
-            </a:avLst>
-          </a:prstGeom>
-          <a:solidFill>
-            <a:srgbClr val="171A24"/>
-          </a:solidFill>
-          <a:ln w="12700">
-            <a:solidFill>
-              <a:srgbClr val="2A2F3D"/>
-            </a:solidFill>
-          </a:ln>
-          <a:effectLst/>
-        </p:spPr>
-        <p:style>
-          <a:lnRef idx="1">
-            <a:schemeClr val="accent1"/>
-          </a:lnRef>
-          <a:fillRef idx="3">
-            <a:schemeClr val="accent1"/>
-          </a:fillRef>
-          <a:effectRef idx="2">
-            <a:schemeClr val="accent1"/>
-          </a:effectRef>
-          <a:fontRef idx="minor">
-            <a:schemeClr val="lt1"/>
-          </a:fontRef>
-        </p:style>
-        <p:txBody>
-          <a:bodyPr rtlCol="0" anchor="ctr"/>
-          <a:lstStyle/>
-          <a:p>
-            <a:pPr algn="ctr"/>
-          </a:p>
-        </p:txBody>
-      </p:sp>
-      <p:sp>
-        <p:nvSpPr>
-          <p:cNvPr id="7" name="TextBox 6"/>
-          <p:cNvSpPr txBox="1"/>
-          <p:nvPr/>
-        </p:nvSpPr>
-        <p:spPr>
-          <a:xfrm>
-            <a:off x="1097280" y="2395728"/>
-            <a:ext cx="4541367" cy="777240"/>
-          </a:xfrm>
-          <a:prstGeom prst="rect">
-            <a:avLst/>
-          </a:prstGeom>
-          <a:noFill/>
-        </p:spPr>
-        <p:txBody>
-          <a:bodyPr wrap="square" anchor="ctr" lIns="0" rIns="0" tIns="0" bIns="0">
-            <a:spAutoFit/>
-          </a:bodyPr>
-          <a:lstStyle/>
-          <a:p>
-            <a:pPr>
-              <a:lnSpc>
-                <a:spcPct val="115000"/>
-              </a:lnSpc>
-            </a:pPr>
-            <a:r>
-              <a:rPr sz="1700" b="1">
-                <a:solidFill>
-                  <a:srgbClr val="5CBD8A"/>
-                </a:solidFill>
-                <a:latin typeface="Segoe UI"/>
-              </a:rPr>
-              <a:t>✓  </a:t>
-            </a:r>
-            <a:r>
-              <a:rPr sz="1500" b="0">
-                <a:solidFill>
-                  <a:srgbClr val="EEF0F6"/>
-                </a:solidFill>
-                <a:latin typeface="Segoe UI"/>
-              </a:rPr>
-              <a:t>Pipeline completo: Explorer → Researcher → Implementer → Tester → Reviewer.</a:t>
-            </a:r>
-          </a:p>
-        </p:txBody>
-      </p:sp>
-      <p:sp>
-        <p:nvSpPr>
-          <p:cNvPr id="8" name="Rounded Rectangle 7"/>
-          <p:cNvSpPr/>
-          <p:nvPr/>
-        </p:nvSpPr>
-        <p:spPr>
-          <a:xfrm>
-            <a:off x="6278727" y="2286000"/>
-            <a:ext cx="5090007" cy="960120"/>
-          </a:xfrm>
-          <a:prstGeom prst="roundRect">
-            <a:avLst>
-              <a:gd name="adj" fmla="val 6000"/>
-            </a:avLst>
-          </a:prstGeom>
-          <a:solidFill>
-            <a:srgbClr val="171A24"/>
-          </a:solidFill>
-          <a:ln w="12700">
-            <a:solidFill>
-              <a:srgbClr val="2A2F3D"/>
-            </a:solidFill>
-          </a:ln>
-          <a:effectLst/>
-        </p:spPr>
-        <p:style>
-          <a:lnRef idx="1">
-            <a:schemeClr val="accent1"/>
-          </a:lnRef>
-          <a:fillRef idx="3">
-            <a:schemeClr val="accent1"/>
-          </a:fillRef>
-          <a:effectRef idx="2">
-            <a:schemeClr val="accent1"/>
-          </a:effectRef>
-          <a:fontRef idx="minor">
-            <a:schemeClr val="lt1"/>
-          </a:fontRef>
-        </p:style>
-        <p:txBody>
-          <a:bodyPr rtlCol="0" anchor="ctr"/>
-          <a:lstStyle/>
-          <a:p>
-            <a:pPr algn="ctr"/>
-          </a:p>
-        </p:txBody>
-      </p:sp>
-      <p:sp>
-        <p:nvSpPr>
-          <p:cNvPr id="9" name="TextBox 8"/>
-          <p:cNvSpPr txBox="1"/>
-          <p:nvPr/>
-        </p:nvSpPr>
-        <p:spPr>
-          <a:xfrm>
-            <a:off x="6553047" y="2395728"/>
-            <a:ext cx="4541367" cy="777240"/>
-          </a:xfrm>
-          <a:prstGeom prst="rect">
-            <a:avLst/>
-          </a:prstGeom>
-          <a:noFill/>
-        </p:spPr>
-        <p:txBody>
-          <a:bodyPr wrap="square" anchor="ctr" lIns="0" rIns="0" tIns="0" bIns="0">
-            <a:spAutoFit/>
-          </a:bodyPr>
-          <a:lstStyle/>
-          <a:p>
-            <a:pPr>
-              <a:lnSpc>
-                <a:spcPct val="115000"/>
-              </a:lnSpc>
-            </a:pPr>
-            <a:r>
-              <a:rPr sz="1700" b="1">
-                <a:solidFill>
-                  <a:srgbClr val="5CBD8A"/>
-                </a:solidFill>
-                <a:latin typeface="Segoe UI"/>
-              </a:rPr>
-              <a:t>✓  </a:t>
-            </a:r>
-            <a:r>
-              <a:rPr sz="1500" b="0">
-                <a:solidFill>
-                  <a:srgbClr val="EEF0F6"/>
-                </a:solidFill>
-                <a:latin typeface="Segoe UI"/>
-              </a:rPr>
-              <a:t>Fuentes diferenciadas por origen en el reporte final.</a:t>
-            </a:r>
-          </a:p>
-        </p:txBody>
-      </p:sp>
-      <p:sp>
-        <p:nvSpPr>
-          <p:cNvPr id="10" name="Rounded Rectangle 9"/>
-          <p:cNvSpPr/>
-          <p:nvPr/>
-        </p:nvSpPr>
-        <p:spPr>
-          <a:xfrm>
-            <a:off x="822960" y="3429000"/>
-            <a:ext cx="5090007" cy="960120"/>
-          </a:xfrm>
-          <a:prstGeom prst="roundRect">
-            <a:avLst>
-              <a:gd name="adj" fmla="val 6000"/>
-            </a:avLst>
-          </a:prstGeom>
-          <a:solidFill>
-            <a:srgbClr val="171A24"/>
-          </a:solidFill>
-          <a:ln w="12700">
-            <a:solidFill>
-              <a:srgbClr val="2A2F3D"/>
-            </a:solidFill>
-          </a:ln>
-          <a:effectLst/>
-        </p:spPr>
-        <p:style>
-          <a:lnRef idx="1">
-            <a:schemeClr val="accent1"/>
-          </a:lnRef>
-          <a:fillRef idx="3">
-            <a:schemeClr val="accent1"/>
-          </a:fillRef>
-          <a:effectRef idx="2">
-            <a:schemeClr val="accent1"/>
-          </a:effectRef>
-          <a:fontRef idx="minor">
-            <a:schemeClr val="lt1"/>
-          </a:fontRef>
-        </p:style>
-        <p:txBody>
-          <a:bodyPr rtlCol="0" anchor="ctr"/>
-          <a:lstStyle/>
-          <a:p>
-            <a:pPr algn="ctr"/>
-          </a:p>
-        </p:txBody>
-      </p:sp>
-      <p:sp>
-        <p:nvSpPr>
-          <p:cNvPr id="11" name="TextBox 10"/>
-          <p:cNvSpPr txBox="1"/>
-          <p:nvPr/>
-        </p:nvSpPr>
-        <p:spPr>
-          <a:xfrm>
-            <a:off x="1097280" y="3538728"/>
-            <a:ext cx="4541367" cy="777240"/>
-          </a:xfrm>
-          <a:prstGeom prst="rect">
-            <a:avLst/>
-          </a:prstGeom>
-          <a:noFill/>
-        </p:spPr>
-        <p:txBody>
-          <a:bodyPr wrap="square" anchor="ctr" lIns="0" rIns="0" tIns="0" bIns="0">
-            <a:spAutoFit/>
-          </a:bodyPr>
-          <a:lstStyle/>
-          <a:p>
-            <a:pPr>
-              <a:lnSpc>
-                <a:spcPct val="115000"/>
-              </a:lnSpc>
-            </a:pPr>
-            <a:r>
-              <a:rPr sz="1700" b="1">
-                <a:solidFill>
-                  <a:srgbClr val="5CBD8A"/>
-                </a:solidFill>
-                <a:latin typeface="Segoe UI"/>
-              </a:rPr>
-              <a:t>✓  </a:t>
-            </a:r>
-            <a:r>
-              <a:rPr sz="1500" b="0">
-                <a:solidFill>
-                  <a:srgbClr val="EEF0F6"/>
-                </a:solidFill>
-                <a:latin typeface="Segoe UI"/>
-              </a:rPr>
-              <a:t>Memoria persistida y reutilizada entre corridas.</a:t>
-            </a:r>
-          </a:p>
-        </p:txBody>
-      </p:sp>
-      <p:sp>
-        <p:nvSpPr>
-          <p:cNvPr id="12" name="Rounded Rectangle 11"/>
-          <p:cNvSpPr/>
-          <p:nvPr/>
-        </p:nvSpPr>
-        <p:spPr>
-          <a:xfrm>
-            <a:off x="6278727" y="3429000"/>
-            <a:ext cx="5090007" cy="960120"/>
-          </a:xfrm>
-          <a:prstGeom prst="roundRect">
-            <a:avLst>
-              <a:gd name="adj" fmla="val 6000"/>
-            </a:avLst>
-          </a:prstGeom>
-          <a:solidFill>
-            <a:srgbClr val="171A24"/>
-          </a:solidFill>
-          <a:ln w="12700">
-            <a:solidFill>
-              <a:srgbClr val="2A2F3D"/>
-            </a:solidFill>
-          </a:ln>
-          <a:effectLst/>
-        </p:spPr>
-        <p:style>
-          <a:lnRef idx="1">
-            <a:schemeClr val="accent1"/>
-          </a:lnRef>
-          <a:fillRef idx="3">
-            <a:schemeClr val="accent1"/>
-          </a:fillRef>
-          <a:effectRef idx="2">
-            <a:schemeClr val="accent1"/>
-          </a:effectRef>
-          <a:fontRef idx="minor">
-            <a:schemeClr val="lt1"/>
-          </a:fontRef>
-        </p:style>
-        <p:txBody>
-          <a:bodyPr rtlCol="0" anchor="ctr"/>
-          <a:lstStyle/>
-          <a:p>
-            <a:pPr algn="ctr"/>
-          </a:p>
-        </p:txBody>
-      </p:sp>
-      <p:sp>
-        <p:nvSpPr>
-          <p:cNvPr id="13" name="TextBox 12"/>
-          <p:cNvSpPr txBox="1"/>
-          <p:nvPr/>
-        </p:nvSpPr>
-        <p:spPr>
-          <a:xfrm>
-            <a:off x="6553047" y="3538728"/>
-            <a:ext cx="4541367" cy="777240"/>
-          </a:xfrm>
-          <a:prstGeom prst="rect">
-            <a:avLst/>
-          </a:prstGeom>
-          <a:noFill/>
-        </p:spPr>
-        <p:txBody>
-          <a:bodyPr wrap="square" anchor="ctr" lIns="0" rIns="0" tIns="0" bIns="0">
-            <a:spAutoFit/>
-          </a:bodyPr>
-          <a:lstStyle/>
-          <a:p>
-            <a:pPr>
-              <a:lnSpc>
-                <a:spcPct val="115000"/>
-              </a:lnSpc>
-            </a:pPr>
-            <a:r>
-              <a:rPr sz="1700" b="1">
-                <a:solidFill>
-                  <a:srgbClr val="5CBD8A"/>
-                </a:solidFill>
-                <a:latin typeface="Segoe UI"/>
-              </a:rPr>
-              <a:t>✓  </a:t>
-            </a:r>
-            <a:r>
-              <a:rPr sz="1500" b="0">
-                <a:solidFill>
-                  <a:srgbClr val="EEF0F6"/>
-                </a:solidFill>
-                <a:latin typeface="Segoe UI"/>
-              </a:rPr>
-              <a:t>Tester corre su check sin modificar archivos indebidos.</a:t>
-            </a:r>
-          </a:p>
-        </p:txBody>
-      </p:sp>
-      <p:sp>
-        <p:nvSpPr>
-          <p:cNvPr id="14" name="Rounded Rectangle 13"/>
-          <p:cNvSpPr/>
-          <p:nvPr/>
-        </p:nvSpPr>
-        <p:spPr>
-          <a:xfrm>
-            <a:off x="822960" y="4572000"/>
-            <a:ext cx="5090007" cy="960120"/>
-          </a:xfrm>
-          <a:prstGeom prst="roundRect">
-            <a:avLst>
-              <a:gd name="adj" fmla="val 6000"/>
-            </a:avLst>
-          </a:prstGeom>
-          <a:solidFill>
-            <a:srgbClr val="171A24"/>
-          </a:solidFill>
-          <a:ln w="12700">
-            <a:solidFill>
-              <a:srgbClr val="2A2F3D"/>
-            </a:solidFill>
-          </a:ln>
-          <a:effectLst/>
-        </p:spPr>
-        <p:style>
-          <a:lnRef idx="1">
-            <a:schemeClr val="accent1"/>
-          </a:lnRef>
-          <a:fillRef idx="3">
-            <a:schemeClr val="accent1"/>
-          </a:fillRef>
-          <a:effectRef idx="2">
-            <a:schemeClr val="accent1"/>
-          </a:effectRef>
-          <a:fontRef idx="minor">
-            <a:schemeClr val="lt1"/>
-          </a:fontRef>
-        </p:style>
-        <p:txBody>
-          <a:bodyPr rtlCol="0" anchor="ctr"/>
-          <a:lstStyle/>
-          <a:p>
-            <a:pPr algn="ctr"/>
-          </a:p>
-        </p:txBody>
-      </p:sp>
-      <p:sp>
-        <p:nvSpPr>
-          <p:cNvPr id="15" name="TextBox 14"/>
-          <p:cNvSpPr txBox="1"/>
-          <p:nvPr/>
-        </p:nvSpPr>
-        <p:spPr>
-          <a:xfrm>
-            <a:off x="1097280" y="4681728"/>
-            <a:ext cx="4541367" cy="777240"/>
-          </a:xfrm>
-          <a:prstGeom prst="rect">
-            <a:avLst/>
-          </a:prstGeom>
-          <a:noFill/>
-        </p:spPr>
-        <p:txBody>
-          <a:bodyPr wrap="square" anchor="ctr" lIns="0" rIns="0" tIns="0" bIns="0">
-            <a:spAutoFit/>
-          </a:bodyPr>
-          <a:lstStyle/>
-          <a:p>
-            <a:pPr>
-              <a:lnSpc>
-                <a:spcPct val="115000"/>
-              </a:lnSpc>
-            </a:pPr>
-            <a:r>
-              <a:rPr sz="1700" b="1">
-                <a:solidFill>
-                  <a:srgbClr val="5CBD8A"/>
-                </a:solidFill>
-                <a:latin typeface="Segoe UI"/>
-              </a:rPr>
-              <a:t>✓  </a:t>
-            </a:r>
-            <a:r>
-              <a:rPr sz="1500" b="0">
-                <a:solidFill>
-                  <a:srgbClr val="EEF0F6"/>
-                </a:solidFill>
-                <a:latin typeface="Segoe UI"/>
-              </a:rPr>
-              <a:t>Falta de evidencia declarada explícitamente cuando corresponde.</a:t>
-            </a:r>
-          </a:p>
-        </p:txBody>
-      </p:sp>
-      <p:sp>
-        <p:nvSpPr>
-          <p:cNvPr id="16" name="Rounded Rectangle 15"/>
-          <p:cNvSpPr/>
-          <p:nvPr/>
-        </p:nvSpPr>
-        <p:spPr>
-          <a:xfrm>
-            <a:off x="6278727" y="4572000"/>
-            <a:ext cx="5090007" cy="960120"/>
-          </a:xfrm>
-          <a:prstGeom prst="roundRect">
-            <a:avLst>
-              <a:gd name="adj" fmla="val 6000"/>
-            </a:avLst>
-          </a:prstGeom>
-          <a:solidFill>
-            <a:srgbClr val="171A24"/>
-          </a:solidFill>
-          <a:ln w="12700">
-            <a:solidFill>
-              <a:srgbClr val="2A2F3D"/>
-            </a:solidFill>
-          </a:ln>
-          <a:effectLst/>
-        </p:spPr>
-        <p:style>
-          <a:lnRef idx="1">
-            <a:schemeClr val="accent1"/>
-          </a:lnRef>
-          <a:fillRef idx="3">
-            <a:schemeClr val="accent1"/>
-          </a:fillRef>
-          <a:effectRef idx="2">
-            <a:schemeClr val="accent1"/>
-          </a:effectRef>
-          <a:fontRef idx="minor">
-            <a:schemeClr val="lt1"/>
-          </a:fontRef>
-        </p:style>
-        <p:txBody>
-          <a:bodyPr rtlCol="0" anchor="ctr"/>
-          <a:lstStyle/>
-          <a:p>
-            <a:pPr algn="ctr"/>
-          </a:p>
-        </p:txBody>
-      </p:sp>
-      <p:sp>
-        <p:nvSpPr>
-          <p:cNvPr id="17" name="TextBox 16"/>
-          <p:cNvSpPr txBox="1"/>
-          <p:nvPr/>
-        </p:nvSpPr>
-        <p:spPr>
-          <a:xfrm>
-            <a:off x="6553047" y="4681728"/>
-            <a:ext cx="4541367" cy="777240"/>
-          </a:xfrm>
-          <a:prstGeom prst="rect">
-            <a:avLst/>
-          </a:prstGeom>
-          <a:noFill/>
-        </p:spPr>
-        <p:txBody>
-          <a:bodyPr wrap="square" anchor="ctr" lIns="0" rIns="0" tIns="0" bIns="0">
-            <a:spAutoFit/>
-          </a:bodyPr>
-          <a:lstStyle/>
-          <a:p>
-            <a:pPr>
-              <a:lnSpc>
-                <a:spcPct val="115000"/>
-              </a:lnSpc>
-            </a:pPr>
-            <a:r>
-              <a:rPr sz="1700" b="1">
-                <a:solidFill>
-                  <a:srgbClr val="5CBD8A"/>
-                </a:solidFill>
-                <a:latin typeface="Segoe UI"/>
-              </a:rPr>
-              <a:t>✓  </a:t>
-            </a:r>
-            <a:r>
-              <a:rPr sz="1500" b="0">
-                <a:solidFill>
-                  <a:srgbClr val="EEF0F6"/>
-                </a:solidFill>
-                <a:latin typeface="Segoe UI"/>
-              </a:rPr>
-              <a:t>Trazas visibles en Langfuse, sin errores fatales.</a:t>
-            </a:r>
-          </a:p>
-        </p:txBody>
-      </p:sp>
-    </p:spTree>
-  </p:cSld>
-  <p:clrMapOvr>
-    <a:masterClrMapping/>
-  </p:clrMapOvr>
-  <p:transition spd="med">
-    <p:fade/>
-  </p:transition>
-</p:sld>
-</file>
-
-<file path=ppt/slides/slide16.xml><?xml version="1.0" encoding="utf-8"?>
 <p:sld xmlns:a="http://schemas.openxmlformats.org/drawingml/2006/main" xmlns:p="http://schemas.openxmlformats.org/presentationml/2006/main" xmlns:r="http://schemas.openxmlformats.org/officeDocument/2006/relationships">
   <p:cSld>
     <p:spTree>

</xml_diff>